<commit_message>
Update workflow overview figure
</commit_message>
<xml_diff>
--- a/man/figures/workflow_overview.pptx
+++ b/man/figures/workflow_overview.pptx
@@ -259,7 +259,7 @@
           <a:p>
             <a:fld id="{FA095A4B-E0B2-984D-AE4F-72FF04A7AC22}" type="datetimeFigureOut">
               <a:rPr lang="en-US" smtClean="0"/>
-              <a:t>7/9/26</a:t>
+              <a:t>9/25/26</a:t>
             </a:fld>
             <a:endParaRPr lang="en-US"/>
           </a:p>
@@ -457,7 +457,7 @@
           <a:p>
             <a:fld id="{FA095A4B-E0B2-984D-AE4F-72FF04A7AC22}" type="datetimeFigureOut">
               <a:rPr lang="en-US" smtClean="0"/>
-              <a:t>7/9/26</a:t>
+              <a:t>9/25/26</a:t>
             </a:fld>
             <a:endParaRPr lang="en-US"/>
           </a:p>
@@ -665,7 +665,7 @@
           <a:p>
             <a:fld id="{FA095A4B-E0B2-984D-AE4F-72FF04A7AC22}" type="datetimeFigureOut">
               <a:rPr lang="en-US" smtClean="0"/>
-              <a:t>7/9/26</a:t>
+              <a:t>9/25/26</a:t>
             </a:fld>
             <a:endParaRPr lang="en-US"/>
           </a:p>
@@ -863,7 +863,7 @@
           <a:p>
             <a:fld id="{FA095A4B-E0B2-984D-AE4F-72FF04A7AC22}" type="datetimeFigureOut">
               <a:rPr lang="en-US" smtClean="0"/>
-              <a:t>7/9/26</a:t>
+              <a:t>9/25/26</a:t>
             </a:fld>
             <a:endParaRPr lang="en-US"/>
           </a:p>
@@ -1138,7 +1138,7 @@
           <a:p>
             <a:fld id="{FA095A4B-E0B2-984D-AE4F-72FF04A7AC22}" type="datetimeFigureOut">
               <a:rPr lang="en-US" smtClean="0"/>
-              <a:t>7/9/26</a:t>
+              <a:t>9/25/26</a:t>
             </a:fld>
             <a:endParaRPr lang="en-US"/>
           </a:p>
@@ -1403,7 +1403,7 @@
           <a:p>
             <a:fld id="{FA095A4B-E0B2-984D-AE4F-72FF04A7AC22}" type="datetimeFigureOut">
               <a:rPr lang="en-US" smtClean="0"/>
-              <a:t>7/9/26</a:t>
+              <a:t>9/25/26</a:t>
             </a:fld>
             <a:endParaRPr lang="en-US"/>
           </a:p>
@@ -1815,7 +1815,7 @@
           <a:p>
             <a:fld id="{FA095A4B-E0B2-984D-AE4F-72FF04A7AC22}" type="datetimeFigureOut">
               <a:rPr lang="en-US" smtClean="0"/>
-              <a:t>7/9/26</a:t>
+              <a:t>9/25/26</a:t>
             </a:fld>
             <a:endParaRPr lang="en-US"/>
           </a:p>
@@ -1956,7 +1956,7 @@
           <a:p>
             <a:fld id="{FA095A4B-E0B2-984D-AE4F-72FF04A7AC22}" type="datetimeFigureOut">
               <a:rPr lang="en-US" smtClean="0"/>
-              <a:t>7/9/26</a:t>
+              <a:t>9/25/26</a:t>
             </a:fld>
             <a:endParaRPr lang="en-US"/>
           </a:p>
@@ -2069,7 +2069,7 @@
           <a:p>
             <a:fld id="{FA095A4B-E0B2-984D-AE4F-72FF04A7AC22}" type="datetimeFigureOut">
               <a:rPr lang="en-US" smtClean="0"/>
-              <a:t>7/9/26</a:t>
+              <a:t>9/25/26</a:t>
             </a:fld>
             <a:endParaRPr lang="en-US"/>
           </a:p>
@@ -2380,7 +2380,7 @@
           <a:p>
             <a:fld id="{FA095A4B-E0B2-984D-AE4F-72FF04A7AC22}" type="datetimeFigureOut">
               <a:rPr lang="en-US" smtClean="0"/>
-              <a:t>7/9/26</a:t>
+              <a:t>9/25/26</a:t>
             </a:fld>
             <a:endParaRPr lang="en-US"/>
           </a:p>
@@ -2668,7 +2668,7 @@
           <a:p>
             <a:fld id="{FA095A4B-E0B2-984D-AE4F-72FF04A7AC22}" type="datetimeFigureOut">
               <a:rPr lang="en-US" smtClean="0"/>
-              <a:t>7/9/26</a:t>
+              <a:t>9/25/26</a:t>
             </a:fld>
             <a:endParaRPr lang="en-US"/>
           </a:p>
@@ -2909,7 +2909,7 @@
           <a:p>
             <a:fld id="{FA095A4B-E0B2-984D-AE4F-72FF04A7AC22}" type="datetimeFigureOut">
               <a:rPr lang="en-US" smtClean="0"/>
-              <a:t>7/9/26</a:t>
+              <a:t>9/25/26</a:t>
             </a:fld>
             <a:endParaRPr lang="en-US"/>
           </a:p>
@@ -4999,8 +4999,8 @@
         </p:blipFill>
         <p:spPr bwMode="auto">
           <a:xfrm>
-            <a:off x="1212140" y="5053290"/>
-            <a:ext cx="1176151" cy="1176151"/>
+            <a:off x="1614058" y="5219314"/>
+            <a:ext cx="822521" cy="822521"/>
           </a:xfrm>
           <a:prstGeom prst="rect">
             <a:avLst/>
@@ -5572,6 +5572,67 @@
           </a:p>
         </p:txBody>
       </p:sp>
+      <p:pic>
+        <p:nvPicPr>
+          <p:cNvPr id="34" name="Picture 33" descr="GBIF logo [IMAGE] | EurekAlert! Science News Releases">
+            <a:extLst>
+              <a:ext uri="{FF2B5EF4-FFF2-40B4-BE49-F238E27FC236}">
+                <a16:creationId xmlns:a16="http://schemas.microsoft.com/office/drawing/2014/main" id="{0DB84CA3-7353-2D61-8C4E-D947833DD7C8}"/>
+              </a:ext>
+            </a:extLst>
+          </p:cNvPr>
+          <p:cNvPicPr>
+            <a:picLocks noChangeAspect="1"/>
+          </p:cNvPicPr>
+          <p:nvPr/>
+        </p:nvPicPr>
+        <p:blipFill>
+          <a:blip r:embed="rId6"/>
+          <a:stretch>
+            <a:fillRect/>
+          </a:stretch>
+        </p:blipFill>
+        <p:spPr>
+          <a:xfrm>
+            <a:off x="791525" y="5157734"/>
+            <a:ext cx="964288" cy="482144"/>
+          </a:xfrm>
+          <a:prstGeom prst="rect">
+            <a:avLst/>
+          </a:prstGeom>
+        </p:spPr>
+      </p:pic>
+      <p:pic>
+        <p:nvPicPr>
+          <p:cNvPr id="35" name="Picture 34" descr="Design logo for geome| concursos de | 99designs">
+            <a:extLst>
+              <a:ext uri="{FF2B5EF4-FFF2-40B4-BE49-F238E27FC236}">
+                <a16:creationId xmlns:a16="http://schemas.microsoft.com/office/drawing/2014/main" id="{51996373-8BB1-6E67-E418-40E0B02F707B}"/>
+              </a:ext>
+            </a:extLst>
+          </p:cNvPr>
+          <p:cNvPicPr>
+            <a:picLocks noChangeAspect="1"/>
+          </p:cNvPicPr>
+          <p:nvPr/>
+        </p:nvPicPr>
+        <p:blipFill>
+          <a:blip r:embed="rId7"/>
+          <a:srcRect l="19288" t="36845" r="19713" b="34594"/>
+          <a:stretch>
+            <a:fillRect/>
+          </a:stretch>
+        </p:blipFill>
+        <p:spPr>
+          <a:xfrm>
+            <a:off x="879682" y="5633403"/>
+            <a:ext cx="788798" cy="369332"/>
+          </a:xfrm>
+          <a:prstGeom prst="rect">
+            <a:avLst/>
+          </a:prstGeom>
+        </p:spPr>
+      </p:pic>
     </p:spTree>
     <p:extLst>
       <p:ext uri="{BB962C8B-B14F-4D97-AF65-F5344CB8AC3E}">

</xml_diff>